<commit_message>
Update SlideReady at /app/slideready
Co-Authored-By: Claude Opus 5.5 <noreply@anthropic.com>
Claude-Session: https://claude.ai/code/session_01FDRLFnf29E4vmY7CG6eeex
</commit_message>
<xml_diff>
--- a/app/slideready/samples/problems.pptx
+++ b/app/slideready/samples/problems.pptx
@@ -13,6 +13,8 @@
     <p:sldId id="261" r:id="rId12"/>
     <p:sldId id="262" r:id="rId13"/>
     <p:sldId id="263" r:id="rId14"/>
+    <p:sldId id="264" r:id="rId15"/>
+    <p:sldId id="265" r:id="rId16"/>
   </p:sldIdLst>
   <p:sldSz cx="12192000" cy="6858000" type="screen4x3"/>
   <p:notesSz cx="6858000" cy="9144000"/>
@@ -3213,6 +3215,1564 @@
 </p:sld>
 </file>
 
+<file path=ppt/slides/slide10.xml><?xml version="1.0" encoding="utf-8"?>
+<p:sld xmlns:a="http://schemas.openxmlformats.org/drawingml/2006/main" xmlns:p="http://schemas.openxmlformats.org/presentationml/2006/main" xmlns:r="http://schemas.openxmlformats.org/officeDocument/2006/relationships">
+  <p:cSld>
+    <p:bg>
+      <p:bgPr>
+        <a:solidFill>
+          <a:srgbClr val="FFFFFF"/>
+        </a:solidFill>
+        <a:effectLst/>
+      </p:bgPr>
+    </p:bg>
+    <p:spTree>
+      <p:nvGrpSpPr>
+        <p:cNvPr id="1" name=""/>
+        <p:cNvGrpSpPr/>
+        <p:nvPr/>
+      </p:nvGrpSpPr>
+      <p:grpSpPr/>
+      <p:sp>
+        <p:nvSpPr>
+          <p:cNvPr id="2" name="TextBox 1"/>
+          <p:cNvSpPr txBox="1"/>
+          <p:nvPr/>
+        </p:nvSpPr>
+        <p:spPr>
+          <a:xfrm>
+            <a:off x="609600" y="274320"/>
+            <a:ext cx="10972800" cy="548640"/>
+          </a:xfrm>
+          <a:prstGeom prst="rect">
+            <a:avLst/>
+          </a:prstGeom>
+          <a:noFill/>
+        </p:spPr>
+        <p:txBody>
+          <a:bodyPr wrap="square">
+            <a:spAutoFit/>
+          </a:bodyPr>
+          <a:lstStyle/>
+          <a:p>
+            <a:r>
+              <a:rPr sz="3200" b="1">
+                <a:solidFill>
+                  <a:srgbClr val="1B1F24"/>
+                </a:solidFill>
+                <a:latin typeface="Carlito"/>
+              </a:rPr>
+              <a:t>System overview</a:t>
+            </a:r>
+          </a:p>
+        </p:txBody>
+      </p:sp>
+      <p:sp>
+        <p:nvSpPr>
+          <p:cNvPr id="3" name="Rounded Rectangle 2"/>
+          <p:cNvSpPr/>
+          <p:nvPr/>
+        </p:nvSpPr>
+        <p:spPr>
+          <a:xfrm>
+            <a:off x="609600" y="1234440"/>
+            <a:ext cx="1706880" cy="685800"/>
+          </a:xfrm>
+          <a:prstGeom prst="roundRect">
+            <a:avLst/>
+          </a:prstGeom>
+          <a:solidFill>
+            <a:srgbClr val="EEF1F6"/>
+          </a:solidFill>
+          <a:ln w="6350">
+            <a:solidFill>
+              <a:srgbClr val="9AA3AD"/>
+            </a:solidFill>
+          </a:ln>
+        </p:spPr>
+        <p:style>
+          <a:lnRef idx="1">
+            <a:schemeClr val="accent1"/>
+          </a:lnRef>
+          <a:fillRef idx="3">
+            <a:schemeClr val="accent1"/>
+          </a:fillRef>
+          <a:effectRef idx="2">
+            <a:schemeClr val="accent1"/>
+          </a:effectRef>
+          <a:fontRef idx="minor">
+            <a:schemeClr val="lt1"/>
+          </a:fontRef>
+        </p:style>
+        <p:txBody>
+          <a:bodyPr rtlCol="0" anchor="ctr"/>
+          <a:lstStyle/>
+          <a:p>
+            <a:r>
+              <a:rPr sz="1000">
+                <a:solidFill>
+                  <a:srgbClr val="3A4252"/>
+                </a:solidFill>
+              </a:rPr>
+              <a:t>Mobile app</a:t>
+            </a:r>
+          </a:p>
+        </p:txBody>
+      </p:sp>
+      <p:sp>
+        <p:nvSpPr>
+          <p:cNvPr id="4" name="Rounded Rectangle 3"/>
+          <p:cNvSpPr/>
+          <p:nvPr/>
+        </p:nvSpPr>
+        <p:spPr>
+          <a:xfrm>
+            <a:off x="2865120" y="1234440"/>
+            <a:ext cx="1706880" cy="685800"/>
+          </a:xfrm>
+          <a:prstGeom prst="roundRect">
+            <a:avLst/>
+          </a:prstGeom>
+          <a:solidFill>
+            <a:srgbClr val="EEF1F6"/>
+          </a:solidFill>
+          <a:ln w="6350">
+            <a:solidFill>
+              <a:srgbClr val="9AA3AD"/>
+            </a:solidFill>
+          </a:ln>
+        </p:spPr>
+        <p:style>
+          <a:lnRef idx="1">
+            <a:schemeClr val="accent1"/>
+          </a:lnRef>
+          <a:fillRef idx="3">
+            <a:schemeClr val="accent1"/>
+          </a:fillRef>
+          <a:effectRef idx="2">
+            <a:schemeClr val="accent1"/>
+          </a:effectRef>
+          <a:fontRef idx="minor">
+            <a:schemeClr val="lt1"/>
+          </a:fontRef>
+        </p:style>
+        <p:txBody>
+          <a:bodyPr rtlCol="0" anchor="ctr"/>
+          <a:lstStyle/>
+          <a:p>
+            <a:r>
+              <a:rPr sz="1000">
+                <a:solidFill>
+                  <a:srgbClr val="3A4252"/>
+                </a:solidFill>
+              </a:rPr>
+              <a:t>Web portal</a:t>
+            </a:r>
+          </a:p>
+        </p:txBody>
+      </p:sp>
+      <p:sp>
+        <p:nvSpPr>
+          <p:cNvPr id="5" name="Rounded Rectangle 4"/>
+          <p:cNvSpPr/>
+          <p:nvPr/>
+        </p:nvSpPr>
+        <p:spPr>
+          <a:xfrm>
+            <a:off x="5120640" y="1234440"/>
+            <a:ext cx="1706880" cy="685800"/>
+          </a:xfrm>
+          <a:prstGeom prst="roundRect">
+            <a:avLst/>
+          </a:prstGeom>
+          <a:solidFill>
+            <a:srgbClr val="EEF1F6"/>
+          </a:solidFill>
+          <a:ln w="6350">
+            <a:solidFill>
+              <a:srgbClr val="9AA3AD"/>
+            </a:solidFill>
+          </a:ln>
+        </p:spPr>
+        <p:style>
+          <a:lnRef idx="1">
+            <a:schemeClr val="accent1"/>
+          </a:lnRef>
+          <a:fillRef idx="3">
+            <a:schemeClr val="accent1"/>
+          </a:fillRef>
+          <a:effectRef idx="2">
+            <a:schemeClr val="accent1"/>
+          </a:effectRef>
+          <a:fontRef idx="minor">
+            <a:schemeClr val="lt1"/>
+          </a:fontRef>
+        </p:style>
+        <p:txBody>
+          <a:bodyPr rtlCol="0" anchor="ctr"/>
+          <a:lstStyle/>
+          <a:p>
+            <a:r>
+              <a:rPr sz="1000">
+                <a:solidFill>
+                  <a:srgbClr val="3A4252"/>
+                </a:solidFill>
+              </a:rPr>
+              <a:t>API gateway</a:t>
+            </a:r>
+          </a:p>
+        </p:txBody>
+      </p:sp>
+      <p:sp>
+        <p:nvSpPr>
+          <p:cNvPr id="6" name="Rounded Rectangle 5"/>
+          <p:cNvSpPr/>
+          <p:nvPr/>
+        </p:nvSpPr>
+        <p:spPr>
+          <a:xfrm>
+            <a:off x="7376160" y="1234440"/>
+            <a:ext cx="1706880" cy="685800"/>
+          </a:xfrm>
+          <a:prstGeom prst="roundRect">
+            <a:avLst/>
+          </a:prstGeom>
+          <a:solidFill>
+            <a:srgbClr val="EEF1F6"/>
+          </a:solidFill>
+          <a:ln w="6350">
+            <a:solidFill>
+              <a:srgbClr val="9AA3AD"/>
+            </a:solidFill>
+          </a:ln>
+        </p:spPr>
+        <p:style>
+          <a:lnRef idx="1">
+            <a:schemeClr val="accent1"/>
+          </a:lnRef>
+          <a:fillRef idx="3">
+            <a:schemeClr val="accent1"/>
+          </a:fillRef>
+          <a:effectRef idx="2">
+            <a:schemeClr val="accent1"/>
+          </a:effectRef>
+          <a:fontRef idx="minor">
+            <a:schemeClr val="lt1"/>
+          </a:fontRef>
+        </p:style>
+        <p:txBody>
+          <a:bodyPr rtlCol="0" anchor="ctr"/>
+          <a:lstStyle/>
+          <a:p>
+            <a:r>
+              <a:rPr sz="1000">
+                <a:solidFill>
+                  <a:srgbClr val="3A4252"/>
+                </a:solidFill>
+              </a:rPr>
+              <a:t>Auth</a:t>
+            </a:r>
+          </a:p>
+        </p:txBody>
+      </p:sp>
+      <p:sp>
+        <p:nvSpPr>
+          <p:cNvPr id="7" name="Rounded Rectangle 6"/>
+          <p:cNvSpPr/>
+          <p:nvPr/>
+        </p:nvSpPr>
+        <p:spPr>
+          <a:xfrm>
+            <a:off x="9631680" y="1234440"/>
+            <a:ext cx="1706880" cy="685800"/>
+          </a:xfrm>
+          <a:prstGeom prst="roundRect">
+            <a:avLst/>
+          </a:prstGeom>
+          <a:solidFill>
+            <a:srgbClr val="EEF1F6"/>
+          </a:solidFill>
+          <a:ln w="6350">
+            <a:solidFill>
+              <a:srgbClr val="9AA3AD"/>
+            </a:solidFill>
+          </a:ln>
+        </p:spPr>
+        <p:style>
+          <a:lnRef idx="1">
+            <a:schemeClr val="accent1"/>
+          </a:lnRef>
+          <a:fillRef idx="3">
+            <a:schemeClr val="accent1"/>
+          </a:fillRef>
+          <a:effectRef idx="2">
+            <a:schemeClr val="accent1"/>
+          </a:effectRef>
+          <a:fontRef idx="minor">
+            <a:schemeClr val="lt1"/>
+          </a:fontRef>
+        </p:style>
+        <p:txBody>
+          <a:bodyPr rtlCol="0" anchor="ctr"/>
+          <a:lstStyle/>
+          <a:p>
+            <a:r>
+              <a:rPr sz="1000">
+                <a:solidFill>
+                  <a:srgbClr val="3A4252"/>
+                </a:solidFill>
+              </a:rPr>
+              <a:t>Dispatch</a:t>
+            </a:r>
+          </a:p>
+        </p:txBody>
+      </p:sp>
+      <p:sp>
+        <p:nvSpPr>
+          <p:cNvPr id="8" name="Rounded Rectangle 7"/>
+          <p:cNvSpPr/>
+          <p:nvPr/>
+        </p:nvSpPr>
+        <p:spPr>
+          <a:xfrm>
+            <a:off x="609600" y="3017520"/>
+            <a:ext cx="1706880" cy="685800"/>
+          </a:xfrm>
+          <a:prstGeom prst="roundRect">
+            <a:avLst/>
+          </a:prstGeom>
+          <a:solidFill>
+            <a:srgbClr val="EEF1F6"/>
+          </a:solidFill>
+          <a:ln w="6350">
+            <a:solidFill>
+              <a:srgbClr val="9AA3AD"/>
+            </a:solidFill>
+          </a:ln>
+        </p:spPr>
+        <p:style>
+          <a:lnRef idx="1">
+            <a:schemeClr val="accent1"/>
+          </a:lnRef>
+          <a:fillRef idx="3">
+            <a:schemeClr val="accent1"/>
+          </a:fillRef>
+          <a:effectRef idx="2">
+            <a:schemeClr val="accent1"/>
+          </a:effectRef>
+          <a:fontRef idx="minor">
+            <a:schemeClr val="lt1"/>
+          </a:fontRef>
+        </p:style>
+        <p:txBody>
+          <a:bodyPr rtlCol="0" anchor="ctr"/>
+          <a:lstStyle/>
+          <a:p>
+            <a:r>
+              <a:rPr sz="1000">
+                <a:solidFill>
+                  <a:srgbClr val="3A4252"/>
+                </a:solidFill>
+              </a:rPr>
+              <a:t>Routing</a:t>
+            </a:r>
+          </a:p>
+        </p:txBody>
+      </p:sp>
+      <p:sp>
+        <p:nvSpPr>
+          <p:cNvPr id="9" name="Rounded Rectangle 8"/>
+          <p:cNvSpPr/>
+          <p:nvPr/>
+        </p:nvSpPr>
+        <p:spPr>
+          <a:xfrm>
+            <a:off x="2865120" y="3017520"/>
+            <a:ext cx="1706880" cy="685800"/>
+          </a:xfrm>
+          <a:prstGeom prst="roundRect">
+            <a:avLst/>
+          </a:prstGeom>
+          <a:solidFill>
+            <a:srgbClr val="EEF1F6"/>
+          </a:solidFill>
+          <a:ln w="6350">
+            <a:solidFill>
+              <a:srgbClr val="9AA3AD"/>
+            </a:solidFill>
+          </a:ln>
+        </p:spPr>
+        <p:style>
+          <a:lnRef idx="1">
+            <a:schemeClr val="accent1"/>
+          </a:lnRef>
+          <a:fillRef idx="3">
+            <a:schemeClr val="accent1"/>
+          </a:fillRef>
+          <a:effectRef idx="2">
+            <a:schemeClr val="accent1"/>
+          </a:effectRef>
+          <a:fontRef idx="minor">
+            <a:schemeClr val="lt1"/>
+          </a:fontRef>
+        </p:style>
+        <p:txBody>
+          <a:bodyPr rtlCol="0" anchor="ctr"/>
+          <a:lstStyle/>
+          <a:p>
+            <a:r>
+              <a:rPr sz="1000">
+                <a:solidFill>
+                  <a:srgbClr val="3A4252"/>
+                </a:solidFill>
+              </a:rPr>
+              <a:t>Scheduler</a:t>
+            </a:r>
+          </a:p>
+        </p:txBody>
+      </p:sp>
+      <p:sp>
+        <p:nvSpPr>
+          <p:cNvPr id="10" name="Rounded Rectangle 9"/>
+          <p:cNvSpPr/>
+          <p:nvPr/>
+        </p:nvSpPr>
+        <p:spPr>
+          <a:xfrm>
+            <a:off x="5120640" y="3017520"/>
+            <a:ext cx="1706880" cy="685800"/>
+          </a:xfrm>
+          <a:prstGeom prst="roundRect">
+            <a:avLst/>
+          </a:prstGeom>
+          <a:solidFill>
+            <a:srgbClr val="EEF1F6"/>
+          </a:solidFill>
+          <a:ln w="6350">
+            <a:solidFill>
+              <a:srgbClr val="9AA3AD"/>
+            </a:solidFill>
+          </a:ln>
+        </p:spPr>
+        <p:style>
+          <a:lnRef idx="1">
+            <a:schemeClr val="accent1"/>
+          </a:lnRef>
+          <a:fillRef idx="3">
+            <a:schemeClr val="accent1"/>
+          </a:fillRef>
+          <a:effectRef idx="2">
+            <a:schemeClr val="accent1"/>
+          </a:effectRef>
+          <a:fontRef idx="minor">
+            <a:schemeClr val="lt1"/>
+          </a:fontRef>
+        </p:style>
+        <p:txBody>
+          <a:bodyPr rtlCol="0" anchor="ctr"/>
+          <a:lstStyle/>
+          <a:p>
+            <a:r>
+              <a:rPr sz="1000">
+                <a:solidFill>
+                  <a:srgbClr val="3A4252"/>
+                </a:solidFill>
+              </a:rPr>
+              <a:t>Billing</a:t>
+            </a:r>
+          </a:p>
+        </p:txBody>
+      </p:sp>
+      <p:sp>
+        <p:nvSpPr>
+          <p:cNvPr id="11" name="Rounded Rectangle 10"/>
+          <p:cNvSpPr/>
+          <p:nvPr/>
+        </p:nvSpPr>
+        <p:spPr>
+          <a:xfrm>
+            <a:off x="7376160" y="3017520"/>
+            <a:ext cx="1706880" cy="685800"/>
+          </a:xfrm>
+          <a:prstGeom prst="roundRect">
+            <a:avLst/>
+          </a:prstGeom>
+          <a:solidFill>
+            <a:srgbClr val="EEF1F6"/>
+          </a:solidFill>
+          <a:ln w="6350">
+            <a:solidFill>
+              <a:srgbClr val="9AA3AD"/>
+            </a:solidFill>
+          </a:ln>
+        </p:spPr>
+        <p:style>
+          <a:lnRef idx="1">
+            <a:schemeClr val="accent1"/>
+          </a:lnRef>
+          <a:fillRef idx="3">
+            <a:schemeClr val="accent1"/>
+          </a:fillRef>
+          <a:effectRef idx="2">
+            <a:schemeClr val="accent1"/>
+          </a:effectRef>
+          <a:fontRef idx="minor">
+            <a:schemeClr val="lt1"/>
+          </a:fontRef>
+        </p:style>
+        <p:txBody>
+          <a:bodyPr rtlCol="0" anchor="ctr"/>
+          <a:lstStyle/>
+          <a:p>
+            <a:r>
+              <a:rPr sz="1000">
+                <a:solidFill>
+                  <a:srgbClr val="3A4252"/>
+                </a:solidFill>
+              </a:rPr>
+              <a:t>Inventory</a:t>
+            </a:r>
+          </a:p>
+        </p:txBody>
+      </p:sp>
+      <p:sp>
+        <p:nvSpPr>
+          <p:cNvPr id="12" name="Rounded Rectangle 11"/>
+          <p:cNvSpPr/>
+          <p:nvPr/>
+        </p:nvSpPr>
+        <p:spPr>
+          <a:xfrm>
+            <a:off x="9631680" y="3017520"/>
+            <a:ext cx="1706880" cy="685800"/>
+          </a:xfrm>
+          <a:prstGeom prst="roundRect">
+            <a:avLst/>
+          </a:prstGeom>
+          <a:solidFill>
+            <a:srgbClr val="EEF1F6"/>
+          </a:solidFill>
+          <a:ln w="6350">
+            <a:solidFill>
+              <a:srgbClr val="9AA3AD"/>
+            </a:solidFill>
+          </a:ln>
+        </p:spPr>
+        <p:style>
+          <a:lnRef idx="1">
+            <a:schemeClr val="accent1"/>
+          </a:lnRef>
+          <a:fillRef idx="3">
+            <a:schemeClr val="accent1"/>
+          </a:fillRef>
+          <a:effectRef idx="2">
+            <a:schemeClr val="accent1"/>
+          </a:effectRef>
+          <a:fontRef idx="minor">
+            <a:schemeClr val="lt1"/>
+          </a:fontRef>
+        </p:style>
+        <p:txBody>
+          <a:bodyPr rtlCol="0" anchor="ctr"/>
+          <a:lstStyle/>
+          <a:p>
+            <a:r>
+              <a:rPr sz="1000">
+                <a:solidFill>
+                  <a:srgbClr val="3A4252"/>
+                </a:solidFill>
+              </a:rPr>
+              <a:t>Notifications</a:t>
+            </a:r>
+          </a:p>
+        </p:txBody>
+      </p:sp>
+      <p:sp>
+        <p:nvSpPr>
+          <p:cNvPr id="13" name="Rounded Rectangle 12"/>
+          <p:cNvSpPr/>
+          <p:nvPr/>
+        </p:nvSpPr>
+        <p:spPr>
+          <a:xfrm>
+            <a:off x="609600" y="4800600"/>
+            <a:ext cx="1706880" cy="685800"/>
+          </a:xfrm>
+          <a:prstGeom prst="roundRect">
+            <a:avLst/>
+          </a:prstGeom>
+          <a:solidFill>
+            <a:srgbClr val="EEF1F6"/>
+          </a:solidFill>
+          <a:ln w="6350">
+            <a:solidFill>
+              <a:srgbClr val="9AA3AD"/>
+            </a:solidFill>
+          </a:ln>
+        </p:spPr>
+        <p:style>
+          <a:lnRef idx="1">
+            <a:schemeClr val="accent1"/>
+          </a:lnRef>
+          <a:fillRef idx="3">
+            <a:schemeClr val="accent1"/>
+          </a:fillRef>
+          <a:effectRef idx="2">
+            <a:schemeClr val="accent1"/>
+          </a:effectRef>
+          <a:fontRef idx="minor">
+            <a:schemeClr val="lt1"/>
+          </a:fontRef>
+        </p:style>
+        <p:txBody>
+          <a:bodyPr rtlCol="0" anchor="ctr"/>
+          <a:lstStyle/>
+          <a:p>
+            <a:r>
+              <a:rPr sz="1000">
+                <a:solidFill>
+                  <a:srgbClr val="3A4252"/>
+                </a:solidFill>
+              </a:rPr>
+              <a:t>Data lake</a:t>
+            </a:r>
+          </a:p>
+        </p:txBody>
+      </p:sp>
+      <p:sp>
+        <p:nvSpPr>
+          <p:cNvPr id="14" name="Rounded Rectangle 13"/>
+          <p:cNvSpPr/>
+          <p:nvPr/>
+        </p:nvSpPr>
+        <p:spPr>
+          <a:xfrm>
+            <a:off x="2865120" y="4800600"/>
+            <a:ext cx="1706880" cy="685800"/>
+          </a:xfrm>
+          <a:prstGeom prst="roundRect">
+            <a:avLst/>
+          </a:prstGeom>
+          <a:solidFill>
+            <a:srgbClr val="EEF1F6"/>
+          </a:solidFill>
+          <a:ln w="6350">
+            <a:solidFill>
+              <a:srgbClr val="9AA3AD"/>
+            </a:solidFill>
+          </a:ln>
+        </p:spPr>
+        <p:style>
+          <a:lnRef idx="1">
+            <a:schemeClr val="accent1"/>
+          </a:lnRef>
+          <a:fillRef idx="3">
+            <a:schemeClr val="accent1"/>
+          </a:fillRef>
+          <a:effectRef idx="2">
+            <a:schemeClr val="accent1"/>
+          </a:effectRef>
+          <a:fontRef idx="minor">
+            <a:schemeClr val="lt1"/>
+          </a:fontRef>
+        </p:style>
+        <p:txBody>
+          <a:bodyPr rtlCol="0" anchor="ctr"/>
+          <a:lstStyle/>
+          <a:p>
+            <a:r>
+              <a:rPr sz="1000">
+                <a:solidFill>
+                  <a:srgbClr val="3A4252"/>
+                </a:solidFill>
+              </a:rPr>
+              <a:t>Reports</a:t>
+            </a:r>
+          </a:p>
+        </p:txBody>
+      </p:sp>
+      <p:sp>
+        <p:nvSpPr>
+          <p:cNvPr id="15" name="Rounded Rectangle 14"/>
+          <p:cNvSpPr/>
+          <p:nvPr/>
+        </p:nvSpPr>
+        <p:spPr>
+          <a:xfrm>
+            <a:off x="5120640" y="4800600"/>
+            <a:ext cx="1706880" cy="685800"/>
+          </a:xfrm>
+          <a:prstGeom prst="roundRect">
+            <a:avLst/>
+          </a:prstGeom>
+          <a:solidFill>
+            <a:srgbClr val="EEF1F6"/>
+          </a:solidFill>
+          <a:ln w="6350">
+            <a:solidFill>
+              <a:srgbClr val="9AA3AD"/>
+            </a:solidFill>
+          </a:ln>
+        </p:spPr>
+        <p:style>
+          <a:lnRef idx="1">
+            <a:schemeClr val="accent1"/>
+          </a:lnRef>
+          <a:fillRef idx="3">
+            <a:schemeClr val="accent1"/>
+          </a:fillRef>
+          <a:effectRef idx="2">
+            <a:schemeClr val="accent1"/>
+          </a:effectRef>
+          <a:fontRef idx="minor">
+            <a:schemeClr val="lt1"/>
+          </a:fontRef>
+        </p:style>
+        <p:txBody>
+          <a:bodyPr rtlCol="0" anchor="ctr"/>
+          <a:lstStyle/>
+          <a:p>
+            <a:r>
+              <a:rPr sz="1000">
+                <a:solidFill>
+                  <a:srgbClr val="3A4252"/>
+                </a:solidFill>
+              </a:rPr>
+              <a:t>CRM sync</a:t>
+            </a:r>
+          </a:p>
+        </p:txBody>
+      </p:sp>
+      <p:sp>
+        <p:nvSpPr>
+          <p:cNvPr id="16" name="Rounded Rectangle 15"/>
+          <p:cNvSpPr/>
+          <p:nvPr/>
+        </p:nvSpPr>
+        <p:spPr>
+          <a:xfrm>
+            <a:off x="7376160" y="4800600"/>
+            <a:ext cx="1706880" cy="685800"/>
+          </a:xfrm>
+          <a:prstGeom prst="roundRect">
+            <a:avLst/>
+          </a:prstGeom>
+          <a:solidFill>
+            <a:srgbClr val="EEF1F6"/>
+          </a:solidFill>
+          <a:ln w="6350">
+            <a:solidFill>
+              <a:srgbClr val="9AA3AD"/>
+            </a:solidFill>
+          </a:ln>
+        </p:spPr>
+        <p:style>
+          <a:lnRef idx="1">
+            <a:schemeClr val="accent1"/>
+          </a:lnRef>
+          <a:fillRef idx="3">
+            <a:schemeClr val="accent1"/>
+          </a:fillRef>
+          <a:effectRef idx="2">
+            <a:schemeClr val="accent1"/>
+          </a:effectRef>
+          <a:fontRef idx="minor">
+            <a:schemeClr val="lt1"/>
+          </a:fontRef>
+        </p:style>
+        <p:txBody>
+          <a:bodyPr rtlCol="0" anchor="ctr"/>
+          <a:lstStyle/>
+          <a:p>
+            <a:r>
+              <a:rPr sz="1000">
+                <a:solidFill>
+                  <a:srgbClr val="3A4252"/>
+                </a:solidFill>
+              </a:rPr>
+              <a:t>Partner feed</a:t>
+            </a:r>
+          </a:p>
+        </p:txBody>
+      </p:sp>
+      <p:cxnSp>
+        <p:nvCxnSpPr>
+          <p:cNvPr id="17" name="Connector 16"/>
+          <p:cNvCxnSpPr/>
+          <p:nvPr/>
+        </p:nvCxnSpPr>
+        <p:spPr>
+          <a:xfrm flipV="1">
+            <a:off x="10485120" y="1577339"/>
+            <a:ext cx="0" cy="1783081"/>
+          </a:xfrm>
+          <a:prstGeom prst="line">
+            <a:avLst/>
+          </a:prstGeom>
+          <a:ln w="6350">
+            <a:solidFill>
+              <a:srgbClr val="9AA3AD"/>
+            </a:solidFill>
+          </a:ln>
+        </p:spPr>
+        <p:style>
+          <a:lnRef idx="2">
+            <a:schemeClr val="accent1"/>
+          </a:lnRef>
+          <a:fillRef idx="0">
+            <a:schemeClr val="accent1"/>
+          </a:fillRef>
+          <a:effectRef idx="1">
+            <a:schemeClr val="accent1"/>
+          </a:effectRef>
+          <a:fontRef idx="minor">
+            <a:schemeClr val="tx1"/>
+          </a:fontRef>
+        </p:style>
+      </p:cxnSp>
+      <p:cxnSp>
+        <p:nvCxnSpPr>
+          <p:cNvPr id="18" name="Connector 17"/>
+          <p:cNvCxnSpPr/>
+          <p:nvPr/>
+        </p:nvCxnSpPr>
+        <p:spPr>
+          <a:xfrm flipH="1" flipV="1">
+            <a:off x="1463040" y="3360420"/>
+            <a:ext cx="2255520" cy="1783080"/>
+          </a:xfrm>
+          <a:prstGeom prst="line">
+            <a:avLst/>
+          </a:prstGeom>
+          <a:ln w="6350">
+            <a:solidFill>
+              <a:srgbClr val="9AA3AD"/>
+            </a:solidFill>
+          </a:ln>
+        </p:spPr>
+        <p:style>
+          <a:lnRef idx="2">
+            <a:schemeClr val="accent1"/>
+          </a:lnRef>
+          <a:fillRef idx="0">
+            <a:schemeClr val="accent1"/>
+          </a:fillRef>
+          <a:effectRef idx="1">
+            <a:schemeClr val="accent1"/>
+          </a:effectRef>
+          <a:fontRef idx="minor">
+            <a:schemeClr val="tx1"/>
+          </a:fontRef>
+        </p:style>
+      </p:cxnSp>
+      <p:cxnSp>
+        <p:nvCxnSpPr>
+          <p:cNvPr id="19" name="Connector 18"/>
+          <p:cNvCxnSpPr/>
+          <p:nvPr/>
+        </p:nvCxnSpPr>
+        <p:spPr>
+          <a:xfrm flipH="1">
+            <a:off x="3718560" y="5143500"/>
+            <a:ext cx="2255520" cy="0"/>
+          </a:xfrm>
+          <a:prstGeom prst="line">
+            <a:avLst/>
+          </a:prstGeom>
+          <a:ln w="6350">
+            <a:solidFill>
+              <a:srgbClr val="9AA3AD"/>
+            </a:solidFill>
+          </a:ln>
+        </p:spPr>
+        <p:style>
+          <a:lnRef idx="2">
+            <a:schemeClr val="accent1"/>
+          </a:lnRef>
+          <a:fillRef idx="0">
+            <a:schemeClr val="accent1"/>
+          </a:fillRef>
+          <a:effectRef idx="1">
+            <a:schemeClr val="accent1"/>
+          </a:effectRef>
+          <a:fontRef idx="minor">
+            <a:schemeClr val="tx1"/>
+          </a:fontRef>
+        </p:style>
+      </p:cxnSp>
+      <p:cxnSp>
+        <p:nvCxnSpPr>
+          <p:cNvPr id="20" name="Connector 19"/>
+          <p:cNvCxnSpPr/>
+          <p:nvPr/>
+        </p:nvCxnSpPr>
+        <p:spPr>
+          <a:xfrm flipH="1">
+            <a:off x="3718560" y="5143500"/>
+            <a:ext cx="4511040" cy="0"/>
+          </a:xfrm>
+          <a:prstGeom prst="line">
+            <a:avLst/>
+          </a:prstGeom>
+          <a:ln w="6350">
+            <a:solidFill>
+              <a:srgbClr val="9AA3AD"/>
+            </a:solidFill>
+          </a:ln>
+        </p:spPr>
+        <p:style>
+          <a:lnRef idx="2">
+            <a:schemeClr val="accent1"/>
+          </a:lnRef>
+          <a:fillRef idx="0">
+            <a:schemeClr val="accent1"/>
+          </a:fillRef>
+          <a:effectRef idx="1">
+            <a:schemeClr val="accent1"/>
+          </a:effectRef>
+          <a:fontRef idx="minor">
+            <a:schemeClr val="tx1"/>
+          </a:fontRef>
+        </p:style>
+      </p:cxnSp>
+      <p:cxnSp>
+        <p:nvCxnSpPr>
+          <p:cNvPr id="21" name="Connector 20"/>
+          <p:cNvCxnSpPr/>
+          <p:nvPr/>
+        </p:nvCxnSpPr>
+        <p:spPr>
+          <a:xfrm flipV="1">
+            <a:off x="1463040" y="3360420"/>
+            <a:ext cx="6766560" cy="1783080"/>
+          </a:xfrm>
+          <a:prstGeom prst="line">
+            <a:avLst/>
+          </a:prstGeom>
+          <a:ln w="6350">
+            <a:solidFill>
+              <a:srgbClr val="9AA3AD"/>
+            </a:solidFill>
+          </a:ln>
+        </p:spPr>
+        <p:style>
+          <a:lnRef idx="2">
+            <a:schemeClr val="accent1"/>
+          </a:lnRef>
+          <a:fillRef idx="0">
+            <a:schemeClr val="accent1"/>
+          </a:fillRef>
+          <a:effectRef idx="1">
+            <a:schemeClr val="accent1"/>
+          </a:effectRef>
+          <a:fontRef idx="minor">
+            <a:schemeClr val="tx1"/>
+          </a:fontRef>
+        </p:style>
+      </p:cxnSp>
+      <p:cxnSp>
+        <p:nvCxnSpPr>
+          <p:cNvPr id="22" name="Connector 21"/>
+          <p:cNvCxnSpPr/>
+          <p:nvPr/>
+        </p:nvCxnSpPr>
+        <p:spPr>
+          <a:xfrm>
+            <a:off x="1463040" y="1577339"/>
+            <a:ext cx="4511040" cy="1783081"/>
+          </a:xfrm>
+          <a:prstGeom prst="line">
+            <a:avLst/>
+          </a:prstGeom>
+          <a:ln w="6350">
+            <a:solidFill>
+              <a:srgbClr val="9AA3AD"/>
+            </a:solidFill>
+          </a:ln>
+        </p:spPr>
+        <p:style>
+          <a:lnRef idx="2">
+            <a:schemeClr val="accent1"/>
+          </a:lnRef>
+          <a:fillRef idx="0">
+            <a:schemeClr val="accent1"/>
+          </a:fillRef>
+          <a:effectRef idx="1">
+            <a:schemeClr val="accent1"/>
+          </a:effectRef>
+          <a:fontRef idx="minor">
+            <a:schemeClr val="tx1"/>
+          </a:fontRef>
+        </p:style>
+      </p:cxnSp>
+      <p:cxnSp>
+        <p:nvCxnSpPr>
+          <p:cNvPr id="23" name="Connector 22"/>
+          <p:cNvCxnSpPr/>
+          <p:nvPr/>
+        </p:nvCxnSpPr>
+        <p:spPr>
+          <a:xfrm flipV="1">
+            <a:off x="5974080" y="1577339"/>
+            <a:ext cx="2255520" cy="3566161"/>
+          </a:xfrm>
+          <a:prstGeom prst="line">
+            <a:avLst/>
+          </a:prstGeom>
+          <a:ln w="6350">
+            <a:solidFill>
+              <a:srgbClr val="9AA3AD"/>
+            </a:solidFill>
+          </a:ln>
+        </p:spPr>
+        <p:style>
+          <a:lnRef idx="2">
+            <a:schemeClr val="accent1"/>
+          </a:lnRef>
+          <a:fillRef idx="0">
+            <a:schemeClr val="accent1"/>
+          </a:fillRef>
+          <a:effectRef idx="1">
+            <a:schemeClr val="accent1"/>
+          </a:effectRef>
+          <a:fontRef idx="minor">
+            <a:schemeClr val="tx1"/>
+          </a:fontRef>
+        </p:style>
+      </p:cxnSp>
+      <p:cxnSp>
+        <p:nvCxnSpPr>
+          <p:cNvPr id="24" name="Connector 23"/>
+          <p:cNvCxnSpPr/>
+          <p:nvPr/>
+        </p:nvCxnSpPr>
+        <p:spPr>
+          <a:xfrm flipV="1">
+            <a:off x="1463040" y="1577339"/>
+            <a:ext cx="0" cy="3566161"/>
+          </a:xfrm>
+          <a:prstGeom prst="line">
+            <a:avLst/>
+          </a:prstGeom>
+          <a:ln w="6350">
+            <a:solidFill>
+              <a:srgbClr val="9AA3AD"/>
+            </a:solidFill>
+          </a:ln>
+        </p:spPr>
+        <p:style>
+          <a:lnRef idx="2">
+            <a:schemeClr val="accent1"/>
+          </a:lnRef>
+          <a:fillRef idx="0">
+            <a:schemeClr val="accent1"/>
+          </a:fillRef>
+          <a:effectRef idx="1">
+            <a:schemeClr val="accent1"/>
+          </a:effectRef>
+          <a:fontRef idx="minor">
+            <a:schemeClr val="tx1"/>
+          </a:fontRef>
+        </p:style>
+      </p:cxnSp>
+      <p:cxnSp>
+        <p:nvCxnSpPr>
+          <p:cNvPr id="25" name="Connector 24"/>
+          <p:cNvCxnSpPr/>
+          <p:nvPr/>
+        </p:nvCxnSpPr>
+        <p:spPr>
+          <a:xfrm flipH="1">
+            <a:off x="3718560" y="1577339"/>
+            <a:ext cx="2255520" cy="0"/>
+          </a:xfrm>
+          <a:prstGeom prst="line">
+            <a:avLst/>
+          </a:prstGeom>
+          <a:ln w="6350">
+            <a:solidFill>
+              <a:srgbClr val="9AA3AD"/>
+            </a:solidFill>
+          </a:ln>
+        </p:spPr>
+        <p:style>
+          <a:lnRef idx="2">
+            <a:schemeClr val="accent1"/>
+          </a:lnRef>
+          <a:fillRef idx="0">
+            <a:schemeClr val="accent1"/>
+          </a:fillRef>
+          <a:effectRef idx="1">
+            <a:schemeClr val="accent1"/>
+          </a:effectRef>
+          <a:fontRef idx="minor">
+            <a:schemeClr val="tx1"/>
+          </a:fontRef>
+        </p:style>
+      </p:cxnSp>
+      <p:cxnSp>
+        <p:nvCxnSpPr>
+          <p:cNvPr id="26" name="Connector 25"/>
+          <p:cNvCxnSpPr/>
+          <p:nvPr/>
+        </p:nvCxnSpPr>
+        <p:spPr>
+          <a:xfrm>
+            <a:off x="1463040" y="3360420"/>
+            <a:ext cx="4511040" cy="0"/>
+          </a:xfrm>
+          <a:prstGeom prst="line">
+            <a:avLst/>
+          </a:prstGeom>
+          <a:ln w="6350">
+            <a:solidFill>
+              <a:srgbClr val="9AA3AD"/>
+            </a:solidFill>
+          </a:ln>
+        </p:spPr>
+        <p:style>
+          <a:lnRef idx="2">
+            <a:schemeClr val="accent1"/>
+          </a:lnRef>
+          <a:fillRef idx="0">
+            <a:schemeClr val="accent1"/>
+          </a:fillRef>
+          <a:effectRef idx="1">
+            <a:schemeClr val="accent1"/>
+          </a:effectRef>
+          <a:fontRef idx="minor">
+            <a:schemeClr val="tx1"/>
+          </a:fontRef>
+        </p:style>
+      </p:cxnSp>
+      <p:cxnSp>
+        <p:nvCxnSpPr>
+          <p:cNvPr id="27" name="Connector 26"/>
+          <p:cNvCxnSpPr/>
+          <p:nvPr/>
+        </p:nvCxnSpPr>
+        <p:spPr>
+          <a:xfrm flipV="1">
+            <a:off x="8229600" y="1577339"/>
+            <a:ext cx="0" cy="3566161"/>
+          </a:xfrm>
+          <a:prstGeom prst="line">
+            <a:avLst/>
+          </a:prstGeom>
+          <a:ln w="6350">
+            <a:solidFill>
+              <a:srgbClr val="9AA3AD"/>
+            </a:solidFill>
+          </a:ln>
+        </p:spPr>
+        <p:style>
+          <a:lnRef idx="2">
+            <a:schemeClr val="accent1"/>
+          </a:lnRef>
+          <a:fillRef idx="0">
+            <a:schemeClr val="accent1"/>
+          </a:fillRef>
+          <a:effectRef idx="1">
+            <a:schemeClr val="accent1"/>
+          </a:effectRef>
+          <a:fontRef idx="minor">
+            <a:schemeClr val="tx1"/>
+          </a:fontRef>
+        </p:style>
+      </p:cxnSp>
+      <p:cxnSp>
+        <p:nvCxnSpPr>
+          <p:cNvPr id="28" name="Connector 27"/>
+          <p:cNvCxnSpPr/>
+          <p:nvPr/>
+        </p:nvCxnSpPr>
+        <p:spPr>
+          <a:xfrm>
+            <a:off x="3718560" y="3360420"/>
+            <a:ext cx="4511040" cy="0"/>
+          </a:xfrm>
+          <a:prstGeom prst="line">
+            <a:avLst/>
+          </a:prstGeom>
+          <a:ln w="6350">
+            <a:solidFill>
+              <a:srgbClr val="9AA3AD"/>
+            </a:solidFill>
+          </a:ln>
+        </p:spPr>
+        <p:style>
+          <a:lnRef idx="2">
+            <a:schemeClr val="accent1"/>
+          </a:lnRef>
+          <a:fillRef idx="0">
+            <a:schemeClr val="accent1"/>
+          </a:fillRef>
+          <a:effectRef idx="1">
+            <a:schemeClr val="accent1"/>
+          </a:effectRef>
+          <a:fontRef idx="minor">
+            <a:schemeClr val="tx1"/>
+          </a:fontRef>
+        </p:style>
+      </p:cxnSp>
+      <p:cxnSp>
+        <p:nvCxnSpPr>
+          <p:cNvPr id="29" name="Connector 28"/>
+          <p:cNvCxnSpPr/>
+          <p:nvPr/>
+        </p:nvCxnSpPr>
+        <p:spPr>
+          <a:xfrm>
+            <a:off x="3718560" y="1577339"/>
+            <a:ext cx="6766560" cy="1783081"/>
+          </a:xfrm>
+          <a:prstGeom prst="line">
+            <a:avLst/>
+          </a:prstGeom>
+          <a:ln w="6350">
+            <a:solidFill>
+              <a:srgbClr val="9AA3AD"/>
+            </a:solidFill>
+          </a:ln>
+        </p:spPr>
+        <p:style>
+          <a:lnRef idx="2">
+            <a:schemeClr val="accent1"/>
+          </a:lnRef>
+          <a:fillRef idx="0">
+            <a:schemeClr val="accent1"/>
+          </a:fillRef>
+          <a:effectRef idx="1">
+            <a:schemeClr val="accent1"/>
+          </a:effectRef>
+          <a:fontRef idx="minor">
+            <a:schemeClr val="tx1"/>
+          </a:fontRef>
+        </p:style>
+      </p:cxnSp>
+      <p:cxnSp>
+        <p:nvCxnSpPr>
+          <p:cNvPr id="30" name="Connector 29"/>
+          <p:cNvCxnSpPr/>
+          <p:nvPr/>
+        </p:nvCxnSpPr>
+        <p:spPr>
+          <a:xfrm flipH="1">
+            <a:off x="1463040" y="1577339"/>
+            <a:ext cx="6766560" cy="0"/>
+          </a:xfrm>
+          <a:prstGeom prst="line">
+            <a:avLst/>
+          </a:prstGeom>
+          <a:ln w="6350">
+            <a:solidFill>
+              <a:srgbClr val="9AA3AD"/>
+            </a:solidFill>
+          </a:ln>
+        </p:spPr>
+        <p:style>
+          <a:lnRef idx="2">
+            <a:schemeClr val="accent1"/>
+          </a:lnRef>
+          <a:fillRef idx="0">
+            <a:schemeClr val="accent1"/>
+          </a:fillRef>
+          <a:effectRef idx="1">
+            <a:schemeClr val="accent1"/>
+          </a:effectRef>
+          <a:fontRef idx="minor">
+            <a:schemeClr val="tx1"/>
+          </a:fontRef>
+        </p:style>
+      </p:cxnSp>
+      <p:cxnSp>
+        <p:nvCxnSpPr>
+          <p:cNvPr id="31" name="Connector 30"/>
+          <p:cNvCxnSpPr/>
+          <p:nvPr/>
+        </p:nvCxnSpPr>
+        <p:spPr>
+          <a:xfrm flipV="1">
+            <a:off x="3718560" y="1577339"/>
+            <a:ext cx="4511040" cy="3566161"/>
+          </a:xfrm>
+          <a:prstGeom prst="line">
+            <a:avLst/>
+          </a:prstGeom>
+          <a:ln w="6350">
+            <a:solidFill>
+              <a:srgbClr val="9AA3AD"/>
+            </a:solidFill>
+          </a:ln>
+        </p:spPr>
+        <p:style>
+          <a:lnRef idx="2">
+            <a:schemeClr val="accent1"/>
+          </a:lnRef>
+          <a:fillRef idx="0">
+            <a:schemeClr val="accent1"/>
+          </a:fillRef>
+          <a:effectRef idx="1">
+            <a:schemeClr val="accent1"/>
+          </a:effectRef>
+          <a:fontRef idx="minor">
+            <a:schemeClr val="tx1"/>
+          </a:fontRef>
+        </p:style>
+      </p:cxnSp>
+      <p:cxnSp>
+        <p:nvCxnSpPr>
+          <p:cNvPr id="32" name="Connector 31"/>
+          <p:cNvCxnSpPr/>
+          <p:nvPr/>
+        </p:nvCxnSpPr>
+        <p:spPr>
+          <a:xfrm flipV="1">
+            <a:off x="3718560" y="1577339"/>
+            <a:ext cx="6766560" cy="1783081"/>
+          </a:xfrm>
+          <a:prstGeom prst="line">
+            <a:avLst/>
+          </a:prstGeom>
+          <a:ln w="6350">
+            <a:solidFill>
+              <a:srgbClr val="9AA3AD"/>
+            </a:solidFill>
+          </a:ln>
+        </p:spPr>
+        <p:style>
+          <a:lnRef idx="2">
+            <a:schemeClr val="accent1"/>
+          </a:lnRef>
+          <a:fillRef idx="0">
+            <a:schemeClr val="accent1"/>
+          </a:fillRef>
+          <a:effectRef idx="1">
+            <a:schemeClr val="accent1"/>
+          </a:effectRef>
+          <a:fontRef idx="minor">
+            <a:schemeClr val="tx1"/>
+          </a:fontRef>
+        </p:style>
+      </p:cxnSp>
+      <p:cxnSp>
+        <p:nvCxnSpPr>
+          <p:cNvPr id="33" name="Connector 32"/>
+          <p:cNvCxnSpPr/>
+          <p:nvPr/>
+        </p:nvCxnSpPr>
+        <p:spPr>
+          <a:xfrm>
+            <a:off x="5974080" y="1577339"/>
+            <a:ext cx="0" cy="3566161"/>
+          </a:xfrm>
+          <a:prstGeom prst="line">
+            <a:avLst/>
+          </a:prstGeom>
+          <a:ln w="6350">
+            <a:solidFill>
+              <a:srgbClr val="9AA3AD"/>
+            </a:solidFill>
+          </a:ln>
+        </p:spPr>
+        <p:style>
+          <a:lnRef idx="2">
+            <a:schemeClr val="accent1"/>
+          </a:lnRef>
+          <a:fillRef idx="0">
+            <a:schemeClr val="accent1"/>
+          </a:fillRef>
+          <a:effectRef idx="1">
+            <a:schemeClr val="accent1"/>
+          </a:effectRef>
+          <a:fontRef idx="minor">
+            <a:schemeClr val="tx1"/>
+          </a:fontRef>
+        </p:style>
+      </p:cxnSp>
+      <p:cxnSp>
+        <p:nvCxnSpPr>
+          <p:cNvPr id="34" name="Connector 33"/>
+          <p:cNvCxnSpPr/>
+          <p:nvPr/>
+        </p:nvCxnSpPr>
+        <p:spPr>
+          <a:xfrm flipV="1">
+            <a:off x="3718560" y="1577339"/>
+            <a:ext cx="2255520" cy="1783081"/>
+          </a:xfrm>
+          <a:prstGeom prst="line">
+            <a:avLst/>
+          </a:prstGeom>
+          <a:ln w="6350">
+            <a:solidFill>
+              <a:srgbClr val="9AA3AD"/>
+            </a:solidFill>
+          </a:ln>
+        </p:spPr>
+        <p:style>
+          <a:lnRef idx="2">
+            <a:schemeClr val="accent1"/>
+          </a:lnRef>
+          <a:fillRef idx="0">
+            <a:schemeClr val="accent1"/>
+          </a:fillRef>
+          <a:effectRef idx="1">
+            <a:schemeClr val="accent1"/>
+          </a:effectRef>
+          <a:fontRef idx="minor">
+            <a:schemeClr val="tx1"/>
+          </a:fontRef>
+        </p:style>
+      </p:cxnSp>
+      <p:cxnSp>
+        <p:nvCxnSpPr>
+          <p:cNvPr id="35" name="Connector 34"/>
+          <p:cNvCxnSpPr/>
+          <p:nvPr/>
+        </p:nvCxnSpPr>
+        <p:spPr>
+          <a:xfrm>
+            <a:off x="5974080" y="5143500"/>
+            <a:ext cx="2255520" cy="0"/>
+          </a:xfrm>
+          <a:prstGeom prst="line">
+            <a:avLst/>
+          </a:prstGeom>
+          <a:ln w="6350">
+            <a:solidFill>
+              <a:srgbClr val="9AA3AD"/>
+            </a:solidFill>
+          </a:ln>
+        </p:spPr>
+        <p:style>
+          <a:lnRef idx="2">
+            <a:schemeClr val="accent1"/>
+          </a:lnRef>
+          <a:fillRef idx="0">
+            <a:schemeClr val="accent1"/>
+          </a:fillRef>
+          <a:effectRef idx="1">
+            <a:schemeClr val="accent1"/>
+          </a:effectRef>
+          <a:fontRef idx="minor">
+            <a:schemeClr val="tx1"/>
+          </a:fontRef>
+        </p:style>
+      </p:cxnSp>
+      <p:cxnSp>
+        <p:nvCxnSpPr>
+          <p:cNvPr id="36" name="Connector 35"/>
+          <p:cNvCxnSpPr/>
+          <p:nvPr/>
+        </p:nvCxnSpPr>
+        <p:spPr>
+          <a:xfrm>
+            <a:off x="3718560" y="1577339"/>
+            <a:ext cx="2255520" cy="0"/>
+          </a:xfrm>
+          <a:prstGeom prst="line">
+            <a:avLst/>
+          </a:prstGeom>
+          <a:ln w="6350">
+            <a:solidFill>
+              <a:srgbClr val="9AA3AD"/>
+            </a:solidFill>
+          </a:ln>
+        </p:spPr>
+        <p:style>
+          <a:lnRef idx="2">
+            <a:schemeClr val="accent1"/>
+          </a:lnRef>
+          <a:fillRef idx="0">
+            <a:schemeClr val="accent1"/>
+          </a:fillRef>
+          <a:effectRef idx="1">
+            <a:schemeClr val="accent1"/>
+          </a:effectRef>
+          <a:fontRef idx="minor">
+            <a:schemeClr val="tx1"/>
+          </a:fontRef>
+        </p:style>
+      </p:cxnSp>
+      <p:cxnSp>
+        <p:nvCxnSpPr>
+          <p:cNvPr id="37" name="Connector 36"/>
+          <p:cNvCxnSpPr/>
+          <p:nvPr/>
+        </p:nvCxnSpPr>
+        <p:spPr>
+          <a:xfrm flipH="1">
+            <a:off x="8229600" y="3360420"/>
+            <a:ext cx="2255520" cy="1783080"/>
+          </a:xfrm>
+          <a:prstGeom prst="line">
+            <a:avLst/>
+          </a:prstGeom>
+          <a:ln w="6350">
+            <a:solidFill>
+              <a:srgbClr val="9AA3AD"/>
+            </a:solidFill>
+          </a:ln>
+        </p:spPr>
+        <p:style>
+          <a:lnRef idx="2">
+            <a:schemeClr val="accent1"/>
+          </a:lnRef>
+          <a:fillRef idx="0">
+            <a:schemeClr val="accent1"/>
+          </a:fillRef>
+          <a:effectRef idx="1">
+            <a:schemeClr val="accent1"/>
+          </a:effectRef>
+          <a:fontRef idx="minor">
+            <a:schemeClr val="tx1"/>
+          </a:fontRef>
+        </p:style>
+      </p:cxnSp>
+      <p:cxnSp>
+        <p:nvCxnSpPr>
+          <p:cNvPr id="38" name="Connector 37"/>
+          <p:cNvCxnSpPr/>
+          <p:nvPr/>
+        </p:nvCxnSpPr>
+        <p:spPr>
+          <a:xfrm flipV="1">
+            <a:off x="5974080" y="1577339"/>
+            <a:ext cx="0" cy="1783081"/>
+          </a:xfrm>
+          <a:prstGeom prst="line">
+            <a:avLst/>
+          </a:prstGeom>
+          <a:ln w="6350">
+            <a:solidFill>
+              <a:srgbClr val="9AA3AD"/>
+            </a:solidFill>
+          </a:ln>
+        </p:spPr>
+        <p:style>
+          <a:lnRef idx="2">
+            <a:schemeClr val="accent1"/>
+          </a:lnRef>
+          <a:fillRef idx="0">
+            <a:schemeClr val="accent1"/>
+          </a:fillRef>
+          <a:effectRef idx="1">
+            <a:schemeClr val="accent1"/>
+          </a:effectRef>
+          <a:fontRef idx="minor">
+            <a:schemeClr val="tx1"/>
+          </a:fontRef>
+        </p:style>
+      </p:cxnSp>
+    </p:spTree>
+  </p:cSld>
+  <p:clrMapOvr>
+    <a:masterClrMapping/>
+  </p:clrMapOvr>
+</p:sld>
+</file>
+
 <file path=ppt/slides/slide2.xml><?xml version="1.0" encoding="utf-8"?>
 <p:sld xmlns:a="http://schemas.openxmlformats.org/drawingml/2006/main" xmlns:p="http://schemas.openxmlformats.org/presentationml/2006/main" xmlns:r="http://schemas.openxmlformats.org/officeDocument/2006/relationships">
   <p:cSld>
@@ -17853,6 +19413,124 @@
                 <a:latin typeface="Carlito"/>
               </a:rPr>
               <a:t>Slides and data: go/fieldops</a:t>
+            </a:r>
+          </a:p>
+        </p:txBody>
+      </p:sp>
+    </p:spTree>
+  </p:cSld>
+  <p:clrMapOvr>
+    <a:masterClrMapping/>
+  </p:clrMapOvr>
+</p:sld>
+</file>
+
+<file path=ppt/slides/slide9.xml><?xml version="1.0" encoding="utf-8"?>
+<p:sld xmlns:a="http://schemas.openxmlformats.org/drawingml/2006/main" xmlns:p="http://schemas.openxmlformats.org/presentationml/2006/main" xmlns:r="http://schemas.openxmlformats.org/officeDocument/2006/relationships">
+  <p:cSld>
+    <p:bg>
+      <p:bgPr>
+        <a:solidFill>
+          <a:srgbClr val="FFFFFF"/>
+        </a:solidFill>
+        <a:effectLst/>
+      </p:bgPr>
+    </p:bg>
+    <p:spTree>
+      <p:nvGrpSpPr>
+        <p:cNvPr id="1" name=""/>
+        <p:cNvGrpSpPr/>
+        <p:nvPr/>
+      </p:nvGrpSpPr>
+      <p:grpSpPr/>
+      <p:pic>
+        <p:nvPicPr>
+          <p:cNvPr id="2" name="Picture 1" descr=".busy-background.png"/>
+          <p:cNvPicPr>
+            <a:picLocks noChangeAspect="1"/>
+          </p:cNvPicPr>
+          <p:nvPr/>
+        </p:nvPicPr>
+        <p:blipFill>
+          <a:blip r:embed="rId2"/>
+          <a:stretch>
+            <a:fillRect/>
+          </a:stretch>
+        </p:blipFill>
+        <p:spPr>
+          <a:xfrm>
+            <a:off x="0" y="0"/>
+            <a:ext cx="12192000" cy="6858000"/>
+          </a:xfrm>
+          <a:prstGeom prst="rect">
+            <a:avLst/>
+          </a:prstGeom>
+        </p:spPr>
+      </p:pic>
+      <p:sp>
+        <p:nvSpPr>
+          <p:cNvPr id="3" name="TextBox 2"/>
+          <p:cNvSpPr txBox="1"/>
+          <p:nvPr/>
+        </p:nvSpPr>
+        <p:spPr>
+          <a:xfrm>
+            <a:off x="975360" y="2606040"/>
+            <a:ext cx="10241280" cy="960120"/>
+          </a:xfrm>
+          <a:prstGeom prst="rect">
+            <a:avLst/>
+          </a:prstGeom>
+          <a:noFill/>
+        </p:spPr>
+        <p:txBody>
+          <a:bodyPr wrap="square">
+            <a:spAutoFit/>
+          </a:bodyPr>
+          <a:lstStyle/>
+          <a:p>
+            <a:r>
+              <a:rPr sz="4000" b="1">
+                <a:solidFill>
+                  <a:srgbClr val="FFFFFF"/>
+                </a:solidFill>
+                <a:latin typeface="Carlito"/>
+              </a:rPr>
+              <a:t>Meet the crews behind the numbers</a:t>
+            </a:r>
+          </a:p>
+        </p:txBody>
+      </p:sp>
+      <p:sp>
+        <p:nvSpPr>
+          <p:cNvPr id="4" name="TextBox 3"/>
+          <p:cNvSpPr txBox="1"/>
+          <p:nvPr/>
+        </p:nvSpPr>
+        <p:spPr>
+          <a:xfrm>
+            <a:off x="975360" y="3703320"/>
+            <a:ext cx="10241280" cy="548640"/>
+          </a:xfrm>
+          <a:prstGeom prst="rect">
+            <a:avLst/>
+          </a:prstGeom>
+          <a:noFill/>
+        </p:spPr>
+        <p:txBody>
+          <a:bodyPr wrap="square">
+            <a:spAutoFit/>
+          </a:bodyPr>
+          <a:lstStyle/>
+          <a:p>
+            <a:r>
+              <a:rPr sz="2400" b="0">
+                <a:solidFill>
+                  <a:srgbClr val="F4F5F7"/>
+                </a:solidFill>
+                <a:latin typeface="Carlito"/>
+              </a:rPr>
+              <a:t>North and Coast regions, spring 2026</a:t>
             </a:r>
           </a:p>
         </p:txBody>

</xml_diff>